<commit_message>
deploy: 2026-07-14 19:27 (build 20260714192715)
</commit_message>
<xml_diff>
--- a/cloudflare-deploy/public/library/agency/agency-en.pptx
+++ b/cloudflare-deploy/public/library/agency/agency-en.pptx
@@ -6,7 +6,7 @@
   </p:sldMasterIdLst>
   <p:sldIdLst>
     <p:sldId id="256" r:id="rId7"/>
-    <p:sldId id="282" r:id="rId33"/>
+    <p:sldId id="283" r:id="rId34"/>
     <p:sldId id="257" r:id="rId8"/>
     <p:sldId id="258" r:id="rId9"/>
     <p:sldId id="259" r:id="rId10"/>
@@ -32,6 +32,7 @@
     <p:sldId id="279" r:id="rId30"/>
     <p:sldId id="280" r:id="rId31"/>
     <p:sldId id="281" r:id="rId32"/>
+    <p:sldId id="282" r:id="rId33"/>
   </p:sldIdLst>
   <p:sldSz cx="12191695" cy="6858000" type="screen4x3"/>
   <p:notesSz cx="6858000" cy="9144000"/>
@@ -15696,6 +15697,992 @@
 </file>
 
 <file path=ppt/slides/slide21.xml><?xml version="1.0" encoding="utf-8"?>
+<p:sld xmlns:a="http://schemas.openxmlformats.org/drawingml/2006/main" xmlns:p="http://schemas.openxmlformats.org/presentationml/2006/main" xmlns:r="http://schemas.openxmlformats.org/officeDocument/2006/relationships">
+  <p:cSld>
+    <p:bg>
+      <p:bgPr>
+        <a:solidFill>
+          <a:srgbClr val="FFFFFF"/>
+        </a:solidFill>
+        <a:effectLst/>
+      </p:bgPr>
+    </p:bg>
+    <p:spTree>
+      <p:nvGrpSpPr>
+        <p:cNvPr id="1" name=""/>
+        <p:cNvGrpSpPr/>
+        <p:nvPr/>
+      </p:nvGrpSpPr>
+      <p:grpSpPr/>
+      <p:sp>
+        <p:nvSpPr>
+          <p:cNvPr id="2" name="Rectangle 1"/>
+          <p:cNvSpPr/>
+          <p:nvPr/>
+        </p:nvSpPr>
+        <p:spPr>
+          <a:xfrm>
+            <a:off x="0" y="0"/>
+            <a:ext cx="12191695" cy="566928"/>
+          </a:xfrm>
+          <a:prstGeom prst="rect">
+            <a:avLst/>
+          </a:prstGeom>
+          <a:solidFill>
+            <a:srgbClr val="E11D48"/>
+          </a:solidFill>
+          <a:ln>
+            <a:noFill/>
+          </a:ln>
+          <a:effectLst/>
+        </p:spPr>
+        <p:style>
+          <a:lnRef idx="1">
+            <a:schemeClr val="accent1"/>
+          </a:lnRef>
+          <a:fillRef idx="3">
+            <a:schemeClr val="accent1"/>
+          </a:fillRef>
+          <a:effectRef idx="2">
+            <a:schemeClr val="accent1"/>
+          </a:effectRef>
+          <a:fontRef idx="minor">
+            <a:schemeClr val="lt1"/>
+          </a:fontRef>
+        </p:style>
+        <p:txBody>
+          <a:bodyPr rtlCol="0" anchor="ctr"/>
+          <a:lstStyle/>
+          <a:p>
+            <a:pPr algn="ctr"/>
+          </a:p>
+        </p:txBody>
+      </p:sp>
+      <p:sp>
+        <p:nvSpPr>
+          <p:cNvPr id="3" name="Rectangle 2"/>
+          <p:cNvSpPr/>
+          <p:nvPr/>
+        </p:nvSpPr>
+        <p:spPr>
+          <a:xfrm>
+            <a:off x="0" y="566928"/>
+            <a:ext cx="12191695" cy="54864"/>
+          </a:xfrm>
+          <a:prstGeom prst="rect">
+            <a:avLst/>
+          </a:prstGeom>
+          <a:solidFill>
+            <a:srgbClr val="0EA5E9"/>
+          </a:solidFill>
+          <a:ln>
+            <a:noFill/>
+          </a:ln>
+          <a:effectLst/>
+        </p:spPr>
+        <p:style>
+          <a:lnRef idx="1">
+            <a:schemeClr val="accent1"/>
+          </a:lnRef>
+          <a:fillRef idx="3">
+            <a:schemeClr val="accent1"/>
+          </a:fillRef>
+          <a:effectRef idx="2">
+            <a:schemeClr val="accent1"/>
+          </a:effectRef>
+          <a:fontRef idx="minor">
+            <a:schemeClr val="lt1"/>
+          </a:fontRef>
+        </p:style>
+        <p:txBody>
+          <a:bodyPr rtlCol="0" anchor="ctr"/>
+          <a:lstStyle/>
+          <a:p>
+            <a:pPr algn="ctr"/>
+          </a:p>
+        </p:txBody>
+      </p:sp>
+      <p:sp>
+        <p:nvSpPr>
+          <p:cNvPr id="4" name="TextBox 3"/>
+          <p:cNvSpPr txBox="1"/>
+          <p:nvPr/>
+        </p:nvSpPr>
+        <p:spPr>
+          <a:xfrm>
+            <a:off x="365760" y="27432"/>
+            <a:ext cx="7315200" cy="502920"/>
+          </a:xfrm>
+          <a:prstGeom prst="rect">
+            <a:avLst/>
+          </a:prstGeom>
+          <a:noFill/>
+        </p:spPr>
+        <p:txBody>
+          <a:bodyPr wrap="square" anchor="ctr">
+            <a:spAutoFit/>
+          </a:bodyPr>
+          <a:lstStyle/>
+          <a:p>
+            <a:pPr algn="l">
+              <a:lnSpc>
+                <a:spcPct val="100000"/>
+              </a:lnSpc>
+            </a:pPr>
+            <a:r>
+              <a:rPr sz="1500" b="1">
+                <a:solidFill>
+                  <a:srgbClr val="FFFFFF"/>
+                </a:solidFill>
+                <a:latin typeface="Malgun Gothic"/>
+              </a:rPr>
+              <a:t>🤝 Mangoi Agency User Guide</a:t>
+            </a:r>
+          </a:p>
+        </p:txBody>
+      </p:sp>
+      <p:sp>
+        <p:nvSpPr>
+          <p:cNvPr id="5" name="TextBox 4"/>
+          <p:cNvSpPr txBox="1"/>
+          <p:nvPr/>
+        </p:nvSpPr>
+        <p:spPr>
+          <a:xfrm>
+            <a:off x="8168335" y="27432"/>
+            <a:ext cx="3657600" cy="502920"/>
+          </a:xfrm>
+          <a:prstGeom prst="rect">
+            <a:avLst/>
+          </a:prstGeom>
+          <a:noFill/>
+        </p:spPr>
+        <p:txBody>
+          <a:bodyPr wrap="square" anchor="ctr">
+            <a:spAutoFit/>
+          </a:bodyPr>
+          <a:lstStyle/>
+          <a:p>
+            <a:pPr algn="r">
+              <a:lnSpc>
+                <a:spcPct val="100000"/>
+              </a:lnSpc>
+            </a:pPr>
+            <a:r>
+              <a:rPr sz="1300" b="1">
+                <a:solidFill>
+                  <a:srgbClr val="F1F5F9"/>
+                </a:solidFill>
+                <a:latin typeface="Malgun Gothic"/>
+              </a:rPr>
+              <a:t>How to Use the Main Features</a:t>
+            </a:r>
+          </a:p>
+        </p:txBody>
+      </p:sp>
+      <p:sp>
+        <p:nvSpPr>
+          <p:cNvPr id="6" name="Rounded Rectangle 5"/>
+          <p:cNvSpPr/>
+          <p:nvPr/>
+        </p:nvSpPr>
+        <p:spPr>
+          <a:xfrm>
+            <a:off x="365760" y="822960"/>
+            <a:ext cx="868680" cy="868680"/>
+          </a:xfrm>
+          <a:prstGeom prst="roundRect">
+            <a:avLst/>
+          </a:prstGeom>
+          <a:solidFill>
+            <a:srgbClr val="E11D48"/>
+          </a:solidFill>
+          <a:ln>
+            <a:noFill/>
+          </a:ln>
+          <a:effectLst/>
+        </p:spPr>
+        <p:style>
+          <a:lnRef idx="1">
+            <a:schemeClr val="accent1"/>
+          </a:lnRef>
+          <a:fillRef idx="3">
+            <a:schemeClr val="accent1"/>
+          </a:fillRef>
+          <a:effectRef idx="2">
+            <a:schemeClr val="accent1"/>
+          </a:effectRef>
+          <a:fontRef idx="minor">
+            <a:schemeClr val="lt1"/>
+          </a:fontRef>
+        </p:style>
+        <p:txBody>
+          <a:bodyPr rtlCol="0" anchor="ctr"/>
+          <a:lstStyle/>
+          <a:p>
+            <a:pPr algn="ctr"/>
+          </a:p>
+        </p:txBody>
+      </p:sp>
+      <p:sp>
+        <p:nvSpPr>
+          <p:cNvPr id="7" name="TextBox 6"/>
+          <p:cNvSpPr txBox="1"/>
+          <p:nvPr/>
+        </p:nvSpPr>
+        <p:spPr>
+          <a:xfrm>
+            <a:off x="365760" y="822960"/>
+            <a:ext cx="868680" cy="868680"/>
+          </a:xfrm>
+          <a:prstGeom prst="rect">
+            <a:avLst/>
+          </a:prstGeom>
+          <a:noFill/>
+        </p:spPr>
+        <p:txBody>
+          <a:bodyPr wrap="square" anchor="ctr">
+            <a:spAutoFit/>
+          </a:bodyPr>
+          <a:lstStyle/>
+          <a:p>
+            <a:pPr algn="ctr">
+              <a:lnSpc>
+                <a:spcPct val="100000"/>
+              </a:lnSpc>
+            </a:pPr>
+            <a:r>
+              <a:rPr sz="2600" b="1">
+                <a:solidFill>
+                  <a:srgbClr val="FFFFFF"/>
+                </a:solidFill>
+                <a:latin typeface="Malgun Gothic"/>
+              </a:rPr>
+              <a:t>19</a:t>
+            </a:r>
+          </a:p>
+        </p:txBody>
+      </p:sp>
+      <p:sp>
+        <p:nvSpPr>
+          <p:cNvPr id="8" name="TextBox 7"/>
+          <p:cNvSpPr txBox="1"/>
+          <p:nvPr/>
+        </p:nvSpPr>
+        <p:spPr>
+          <a:xfrm>
+            <a:off x="1371600" y="822960"/>
+            <a:ext cx="10424160" cy="502920"/>
+          </a:xfrm>
+          <a:prstGeom prst="rect">
+            <a:avLst/>
+          </a:prstGeom>
+          <a:noFill/>
+        </p:spPr>
+        <p:txBody>
+          <a:bodyPr wrap="square" anchor="t">
+            <a:spAutoFit/>
+          </a:bodyPr>
+          <a:lstStyle/>
+          <a:p>
+            <a:pPr algn="l">
+              <a:lnSpc>
+                <a:spcPct val="100000"/>
+              </a:lnSpc>
+            </a:pPr>
+            <a:r>
+              <a:rPr sz="2300" b="1">
+                <a:solidFill>
+                  <a:srgbClr val="1E2340"/>
+                </a:solidFill>
+                <a:latin typeface="Malgun Gothic"/>
+              </a:rPr>
+              <a:t>💬 Share Library Links via KakaoTalk</a:t>
+            </a:r>
+          </a:p>
+        </p:txBody>
+      </p:sp>
+      <p:sp>
+        <p:nvSpPr>
+          <p:cNvPr id="9" name="TextBox 8"/>
+          <p:cNvSpPr txBox="1"/>
+          <p:nvPr/>
+        </p:nvSpPr>
+        <p:spPr>
+          <a:xfrm>
+            <a:off x="1417320" y="1353312"/>
+            <a:ext cx="10424160" cy="320040"/>
+          </a:xfrm>
+          <a:prstGeom prst="rect">
+            <a:avLst/>
+          </a:prstGeom>
+          <a:noFill/>
+        </p:spPr>
+        <p:txBody>
+          <a:bodyPr wrap="square" anchor="t">
+            <a:spAutoFit/>
+          </a:bodyPr>
+          <a:lstStyle/>
+          <a:p>
+            <a:pPr algn="l">
+              <a:lnSpc>
+                <a:spcPct val="100000"/>
+              </a:lnSpc>
+            </a:pPr>
+            <a:r>
+              <a:rPr sz="1300" b="0">
+                <a:solidFill>
+                  <a:srgbClr val="64748B"/>
+                </a:solidFill>
+                <a:latin typeface="Malgun Gothic"/>
+              </a:rPr>
+              <a:t>Send videos &amp; docs in original quality</a:t>
+            </a:r>
+          </a:p>
+        </p:txBody>
+      </p:sp>
+      <p:sp>
+        <p:nvSpPr>
+          <p:cNvPr id="10" name="Rounded Rectangle 9"/>
+          <p:cNvSpPr/>
+          <p:nvPr/>
+        </p:nvSpPr>
+        <p:spPr>
+          <a:xfrm>
+            <a:off x="365760" y="1828800"/>
+            <a:ext cx="11430000" cy="777240"/>
+          </a:xfrm>
+          <a:prstGeom prst="roundRect">
+            <a:avLst/>
+          </a:prstGeom>
+          <a:solidFill>
+            <a:srgbClr val="FFF1F2"/>
+          </a:solidFill>
+          <a:ln>
+            <a:noFill/>
+          </a:ln>
+          <a:effectLst/>
+        </p:spPr>
+        <p:style>
+          <a:lnRef idx="1">
+            <a:schemeClr val="accent1"/>
+          </a:lnRef>
+          <a:fillRef idx="3">
+            <a:schemeClr val="accent1"/>
+          </a:fillRef>
+          <a:effectRef idx="2">
+            <a:schemeClr val="accent1"/>
+          </a:effectRef>
+          <a:fontRef idx="minor">
+            <a:schemeClr val="lt1"/>
+          </a:fontRef>
+        </p:style>
+        <p:txBody>
+          <a:bodyPr rtlCol="0" anchor="ctr"/>
+          <a:lstStyle/>
+          <a:p>
+            <a:pPr algn="ctr"/>
+          </a:p>
+        </p:txBody>
+      </p:sp>
+      <p:sp>
+        <p:nvSpPr>
+          <p:cNvPr id="11" name="TextBox 10"/>
+          <p:cNvSpPr txBox="1"/>
+          <p:nvPr/>
+        </p:nvSpPr>
+        <p:spPr>
+          <a:xfrm>
+            <a:off x="548640" y="1901952"/>
+            <a:ext cx="11064240" cy="640080"/>
+          </a:xfrm>
+          <a:prstGeom prst="rect">
+            <a:avLst/>
+          </a:prstGeom>
+          <a:noFill/>
+        </p:spPr>
+        <p:txBody>
+          <a:bodyPr wrap="square" anchor="t">
+            <a:spAutoFit/>
+          </a:bodyPr>
+          <a:lstStyle/>
+          <a:p>
+            <a:pPr algn="l">
+              <a:lnSpc>
+                <a:spcPct val="115000"/>
+              </a:lnSpc>
+            </a:pPr>
+            <a:r>
+              <a:rPr sz="1200" b="0">
+                <a:solidFill>
+                  <a:srgbClr val="334155"/>
+                </a:solidFill>
+                <a:latin typeface="Malgun Gothic"/>
+              </a:rPr>
+              <a:t>Every guide and video in the library now has a '💬 Copy KakaoTalk link' button. Attaching a file to KakaoTalk crushes the quality, but sending a link plays the original as-is. One tap copies the link — guiding parents and teachers gets much easier.</a:t>
+            </a:r>
+          </a:p>
+        </p:txBody>
+      </p:sp>
+      <p:sp>
+        <p:nvSpPr>
+          <p:cNvPr id="12" name="TextBox 11"/>
+          <p:cNvSpPr txBox="1"/>
+          <p:nvPr/>
+        </p:nvSpPr>
+        <p:spPr>
+          <a:xfrm>
+            <a:off x="457200" y="2743200"/>
+            <a:ext cx="5669280" cy="320040"/>
+          </a:xfrm>
+          <a:prstGeom prst="rect">
+            <a:avLst/>
+          </a:prstGeom>
+          <a:noFill/>
+        </p:spPr>
+        <p:txBody>
+          <a:bodyPr wrap="square" anchor="t">
+            <a:spAutoFit/>
+          </a:bodyPr>
+          <a:lstStyle/>
+          <a:p>
+            <a:pPr algn="l">
+              <a:lnSpc>
+                <a:spcPct val="100000"/>
+              </a:lnSpc>
+            </a:pPr>
+            <a:r>
+              <a:rPr sz="1350" b="1">
+                <a:solidFill>
+                  <a:srgbClr val="E11D48"/>
+                </a:solidFill>
+                <a:latin typeface="Malgun Gothic"/>
+              </a:rPr>
+              <a:t>How to use</a:t>
+            </a:r>
+          </a:p>
+        </p:txBody>
+      </p:sp>
+      <p:sp>
+        <p:nvSpPr>
+          <p:cNvPr id="13" name="TextBox 12"/>
+          <p:cNvSpPr txBox="1"/>
+          <p:nvPr/>
+        </p:nvSpPr>
+        <p:spPr>
+          <a:xfrm>
+            <a:off x="457200" y="3108960"/>
+            <a:ext cx="5669280" cy="2377440"/>
+          </a:xfrm>
+          <a:prstGeom prst="rect">
+            <a:avLst/>
+          </a:prstGeom>
+          <a:noFill/>
+        </p:spPr>
+        <p:txBody>
+          <a:bodyPr wrap="square">
+            <a:spAutoFit/>
+          </a:bodyPr>
+          <a:lstStyle/>
+          <a:p>
+            <a:pPr>
+              <a:lnSpc>
+                <a:spcPct val="115000"/>
+              </a:lnSpc>
+              <a:spcAft>
+                <a:spcPts val="600"/>
+              </a:spcAft>
+            </a:pPr>
+            <a:r>
+              <a:rPr sz="1050" b="1">
+                <a:solidFill>
+                  <a:srgbClr val="E11D48"/>
+                </a:solidFill>
+                <a:latin typeface="Malgun Gothic"/>
+              </a:rPr>
+              <a:t>● </a:t>
+            </a:r>
+            <a:r>
+              <a:rPr sz="1250">
+                <a:solidFill>
+                  <a:srgbClr val="334155"/>
+                </a:solidFill>
+                <a:latin typeface="Malgun Gothic"/>
+              </a:rPr>
+              <a:t>In the admin Library, press 💬 Copy KakaoTalk link next to the file.</a:t>
+            </a:r>
+          </a:p>
+          <a:p>
+            <a:pPr>
+              <a:lnSpc>
+                <a:spcPct val="115000"/>
+              </a:lnSpc>
+              <a:spcAft>
+                <a:spcPts val="600"/>
+              </a:spcAft>
+            </a:pPr>
+            <a:r>
+              <a:rPr sz="1050" b="1">
+                <a:solidFill>
+                  <a:srgbClr val="E11D48"/>
+                </a:solidFill>
+                <a:latin typeface="Malgun Gothic"/>
+              </a:rPr>
+              <a:t>● </a:t>
+            </a:r>
+            <a:r>
+              <a:rPr sz="1250">
+                <a:solidFill>
+                  <a:srgbClr val="334155"/>
+                </a:solidFill>
+                <a:latin typeface="Malgun Gothic"/>
+              </a:rPr>
+              <a:t>Paste it into the KakaoTalk chat room.</a:t>
+            </a:r>
+          </a:p>
+          <a:p>
+            <a:pPr>
+              <a:lnSpc>
+                <a:spcPct val="115000"/>
+              </a:lnSpc>
+              <a:spcAft>
+                <a:spcPts val="600"/>
+              </a:spcAft>
+            </a:pPr>
+            <a:r>
+              <a:rPr sz="1050" b="1">
+                <a:solidFill>
+                  <a:srgbClr val="E11D48"/>
+                </a:solidFill>
+                <a:latin typeface="Malgun Gothic"/>
+              </a:rPr>
+              <a:t>● </a:t>
+            </a:r>
+            <a:r>
+              <a:rPr sz="1250">
+                <a:solidFill>
+                  <a:srgbClr val="334155"/>
+                </a:solidFill>
+                <a:latin typeface="Malgun Gothic"/>
+              </a:rPr>
+              <a:t>Recipients tap the link to watch or download in original quality.</a:t>
+            </a:r>
+          </a:p>
+        </p:txBody>
+      </p:sp>
+      <p:sp>
+        <p:nvSpPr>
+          <p:cNvPr id="14" name="Rounded Rectangle 13"/>
+          <p:cNvSpPr/>
+          <p:nvPr/>
+        </p:nvSpPr>
+        <p:spPr>
+          <a:xfrm>
+            <a:off x="457200" y="4398264"/>
+            <a:ext cx="5669280" cy="1005840"/>
+          </a:xfrm>
+          <a:prstGeom prst="roundRect">
+            <a:avLst/>
+          </a:prstGeom>
+          <a:solidFill>
+            <a:srgbClr val="F4F7FF"/>
+          </a:solidFill>
+          <a:ln w="12700">
+            <a:solidFill>
+              <a:srgbClr val="E11D48"/>
+            </a:solidFill>
+          </a:ln>
+          <a:effectLst/>
+        </p:spPr>
+        <p:style>
+          <a:lnRef idx="1">
+            <a:schemeClr val="accent1"/>
+          </a:lnRef>
+          <a:fillRef idx="3">
+            <a:schemeClr val="accent1"/>
+          </a:fillRef>
+          <a:effectRef idx="2">
+            <a:schemeClr val="accent1"/>
+          </a:effectRef>
+          <a:fontRef idx="minor">
+            <a:schemeClr val="lt1"/>
+          </a:fontRef>
+        </p:style>
+        <p:txBody>
+          <a:bodyPr rtlCol="0" anchor="ctr"/>
+          <a:lstStyle/>
+          <a:p>
+            <a:pPr algn="ctr"/>
+          </a:p>
+        </p:txBody>
+      </p:sp>
+      <p:sp>
+        <p:nvSpPr>
+          <p:cNvPr id="15" name="TextBox 14"/>
+          <p:cNvSpPr txBox="1"/>
+          <p:nvPr/>
+        </p:nvSpPr>
+        <p:spPr>
+          <a:xfrm>
+            <a:off x="594360" y="4453127"/>
+            <a:ext cx="5394960" cy="274320"/>
+          </a:xfrm>
+          <a:prstGeom prst="rect">
+            <a:avLst/>
+          </a:prstGeom>
+          <a:noFill/>
+        </p:spPr>
+        <p:txBody>
+          <a:bodyPr wrap="square" anchor="t">
+            <a:spAutoFit/>
+          </a:bodyPr>
+          <a:lstStyle/>
+          <a:p>
+            <a:pPr algn="l">
+              <a:lnSpc>
+                <a:spcPct val="100000"/>
+              </a:lnSpc>
+            </a:pPr>
+            <a:r>
+              <a:rPr sz="1150" b="1">
+                <a:solidFill>
+                  <a:srgbClr val="E11D48"/>
+                </a:solidFill>
+                <a:latin typeface="Malgun Gothic"/>
+              </a:rPr>
+              <a:t>✅ Key Points</a:t>
+            </a:r>
+          </a:p>
+        </p:txBody>
+      </p:sp>
+      <p:sp>
+        <p:nvSpPr>
+          <p:cNvPr id="16" name="TextBox 15"/>
+          <p:cNvSpPr txBox="1"/>
+          <p:nvPr/>
+        </p:nvSpPr>
+        <p:spPr>
+          <a:xfrm>
+            <a:off x="594360" y="4727448"/>
+            <a:ext cx="5394960" cy="640080"/>
+          </a:xfrm>
+          <a:prstGeom prst="rect">
+            <a:avLst/>
+          </a:prstGeom>
+          <a:noFill/>
+        </p:spPr>
+        <p:txBody>
+          <a:bodyPr wrap="square">
+            <a:spAutoFit/>
+          </a:bodyPr>
+          <a:lstStyle/>
+          <a:p>
+            <a:pPr>
+              <a:lnSpc>
+                <a:spcPct val="115000"/>
+              </a:lnSpc>
+              <a:spcAft>
+                <a:spcPts val="200"/>
+              </a:spcAft>
+            </a:pPr>
+            <a:r>
+              <a:rPr sz="900" b="1">
+                <a:solidFill>
+                  <a:srgbClr val="E11D48"/>
+                </a:solidFill>
+                <a:latin typeface="Malgun Gothic"/>
+              </a:rPr>
+              <a:t>● </a:t>
+            </a:r>
+            <a:r>
+              <a:rPr sz="1100">
+                <a:solidFill>
+                  <a:srgbClr val="334155"/>
+                </a:solidFill>
+                <a:latin typeface="Malgun Gothic"/>
+              </a:rPr>
+              <a:t>For videos, link sharing = original quality; file attachments degrade it.</a:t>
+            </a:r>
+          </a:p>
+          <a:p>
+            <a:pPr>
+              <a:lnSpc>
+                <a:spcPct val="115000"/>
+              </a:lnSpc>
+              <a:spcAft>
+                <a:spcPts val="200"/>
+              </a:spcAft>
+            </a:pPr>
+            <a:r>
+              <a:rPr sz="900" b="1">
+                <a:solidFill>
+                  <a:srgbClr val="E11D48"/>
+                </a:solidFill>
+                <a:latin typeface="Malgun Gothic"/>
+              </a:rPr>
+              <a:t>● </a:t>
+            </a:r>
+            <a:r>
+              <a:rPr sz="1100">
+                <a:solidFill>
+                  <a:srgbClr val="334155"/>
+                </a:solidFill>
+                <a:latin typeface="Malgun Gothic"/>
+              </a:rPr>
+              <a:t>Works the same for PDFs, PPTs, and videos anywhere in the library.</a:t>
+            </a:r>
+          </a:p>
+        </p:txBody>
+      </p:sp>
+      <p:sp>
+        <p:nvSpPr>
+          <p:cNvPr id="17" name="Rounded Rectangle 16"/>
+          <p:cNvSpPr/>
+          <p:nvPr/>
+        </p:nvSpPr>
+        <p:spPr>
+          <a:xfrm>
+            <a:off x="457200" y="5513831"/>
+            <a:ext cx="5669280" cy="640080"/>
+          </a:xfrm>
+          <a:prstGeom prst="roundRect">
+            <a:avLst/>
+          </a:prstGeom>
+          <a:solidFill>
+            <a:srgbClr val="FFFBEB"/>
+          </a:solidFill>
+          <a:ln w="12700">
+            <a:solidFill>
+              <a:srgbClr val="F59E0B"/>
+            </a:solidFill>
+          </a:ln>
+          <a:effectLst/>
+        </p:spPr>
+        <p:style>
+          <a:lnRef idx="1">
+            <a:schemeClr val="accent1"/>
+          </a:lnRef>
+          <a:fillRef idx="3">
+            <a:schemeClr val="accent1"/>
+          </a:fillRef>
+          <a:effectRef idx="2">
+            <a:schemeClr val="accent1"/>
+          </a:effectRef>
+          <a:fontRef idx="minor">
+            <a:schemeClr val="lt1"/>
+          </a:fontRef>
+        </p:style>
+        <p:txBody>
+          <a:bodyPr rtlCol="0" anchor="ctr"/>
+          <a:lstStyle/>
+          <a:p>
+            <a:pPr algn="ctr"/>
+          </a:p>
+        </p:txBody>
+      </p:sp>
+      <p:sp>
+        <p:nvSpPr>
+          <p:cNvPr id="18" name="TextBox 17"/>
+          <p:cNvSpPr txBox="1"/>
+          <p:nvPr/>
+        </p:nvSpPr>
+        <p:spPr>
+          <a:xfrm>
+            <a:off x="594360" y="5559551"/>
+            <a:ext cx="5394960" cy="548640"/>
+          </a:xfrm>
+          <a:prstGeom prst="rect">
+            <a:avLst/>
+          </a:prstGeom>
+          <a:noFill/>
+        </p:spPr>
+        <p:txBody>
+          <a:bodyPr wrap="square" anchor="t">
+            <a:spAutoFit/>
+          </a:bodyPr>
+          <a:lstStyle/>
+          <a:p>
+            <a:pPr algn="l">
+              <a:lnSpc>
+                <a:spcPct val="105000"/>
+              </a:lnSpc>
+            </a:pPr>
+            <a:r>
+              <a:rPr sz="1050" b="0">
+                <a:solidFill>
+                  <a:srgbClr val="92670A"/>
+                </a:solidFill>
+                <a:latin typeface="Malgun Gothic"/>
+              </a:rPr>
+              <a:t>⚠️ Good to know · Anyone with the link can open it. For internal-only material, check who you share with.</a:t>
+            </a:r>
+          </a:p>
+        </p:txBody>
+      </p:sp>
+      <p:sp>
+        <p:nvSpPr>
+          <p:cNvPr id="19" name="Rounded Rectangle 18"/>
+          <p:cNvSpPr/>
+          <p:nvPr/>
+        </p:nvSpPr>
+        <p:spPr>
+          <a:xfrm>
+            <a:off x="457200" y="6245351"/>
+            <a:ext cx="5669280" cy="658368"/>
+          </a:xfrm>
+          <a:prstGeom prst="roundRect">
+            <a:avLst/>
+          </a:prstGeom>
+          <a:solidFill>
+            <a:srgbClr val="FFF7E6"/>
+          </a:solidFill>
+          <a:ln w="12700">
+            <a:solidFill>
+              <a:srgbClr val="0EA5E9"/>
+            </a:solidFill>
+          </a:ln>
+          <a:effectLst/>
+        </p:spPr>
+        <p:style>
+          <a:lnRef idx="1">
+            <a:schemeClr val="accent1"/>
+          </a:lnRef>
+          <a:fillRef idx="3">
+            <a:schemeClr val="accent1"/>
+          </a:fillRef>
+          <a:effectRef idx="2">
+            <a:schemeClr val="accent1"/>
+          </a:effectRef>
+          <a:fontRef idx="minor">
+            <a:schemeClr val="lt1"/>
+          </a:fontRef>
+        </p:style>
+        <p:txBody>
+          <a:bodyPr rtlCol="0" anchor="ctr"/>
+          <a:lstStyle/>
+          <a:p>
+            <a:pPr algn="ctr"/>
+          </a:p>
+        </p:txBody>
+      </p:sp>
+      <p:sp>
+        <p:nvSpPr>
+          <p:cNvPr id="20" name="TextBox 19"/>
+          <p:cNvSpPr txBox="1"/>
+          <p:nvPr/>
+        </p:nvSpPr>
+        <p:spPr>
+          <a:xfrm>
+            <a:off x="594360" y="6291071"/>
+            <a:ext cx="5394960" cy="566928"/>
+          </a:xfrm>
+          <a:prstGeom prst="rect">
+            <a:avLst/>
+          </a:prstGeom>
+          <a:noFill/>
+        </p:spPr>
+        <p:txBody>
+          <a:bodyPr wrap="square" anchor="t">
+            <a:spAutoFit/>
+          </a:bodyPr>
+          <a:lstStyle/>
+          <a:p>
+            <a:pPr algn="l">
+              <a:lnSpc>
+                <a:spcPct val="105000"/>
+              </a:lnSpc>
+            </a:pPr>
+            <a:r>
+              <a:rPr sz="1050" b="0">
+                <a:solidFill>
+                  <a:srgbClr val="5B4A2A"/>
+                </a:solidFill>
+                <a:latin typeface="Malgun Gothic"/>
+              </a:rPr>
+              <a:t>💡 Tip · In a parents' group chat, one video-guide link does all the explaining.</a:t>
+            </a:r>
+          </a:p>
+        </p:txBody>
+      </p:sp>
+      <p:sp>
+        <p:nvSpPr>
+          <p:cNvPr id="21" name="Rectangle 20"/>
+          <p:cNvSpPr/>
+          <p:nvPr/>
+        </p:nvSpPr>
+        <p:spPr>
+          <a:xfrm>
+            <a:off x="6300216" y="2345436"/>
+            <a:ext cx="5596128" cy="3538728"/>
+          </a:xfrm>
+          <a:prstGeom prst="rect">
+            <a:avLst/>
+          </a:prstGeom>
+          <a:solidFill>
+            <a:srgbClr val="FFFFFF"/>
+          </a:solidFill>
+          <a:ln w="12700">
+            <a:solidFill>
+              <a:srgbClr val="E2E8F0"/>
+            </a:solidFill>
+          </a:ln>
+          <a:effectLst/>
+        </p:spPr>
+        <p:style>
+          <a:lnRef idx="1">
+            <a:schemeClr val="accent1"/>
+          </a:lnRef>
+          <a:fillRef idx="3">
+            <a:schemeClr val="accent1"/>
+          </a:fillRef>
+          <a:effectRef idx="2">
+            <a:schemeClr val="accent1"/>
+          </a:effectRef>
+          <a:fontRef idx="minor">
+            <a:schemeClr val="lt1"/>
+          </a:fontRef>
+        </p:style>
+        <p:txBody>
+          <a:bodyPr rtlCol="0" anchor="ctr"/>
+          <a:lstStyle/>
+          <a:p>
+            <a:pPr algn="ctr"/>
+          </a:p>
+        </p:txBody>
+      </p:sp>
+      <p:pic>
+        <p:nvPicPr>
+          <p:cNvPr id="22" name="Picture 21" descr="admin_noticestudio.jpg"/>
+          <p:cNvPicPr>
+            <a:picLocks noChangeAspect="1"/>
+          </p:cNvPicPr>
+          <p:nvPr/>
+        </p:nvPicPr>
+        <p:blipFill>
+          <a:blip r:embed="rId2"/>
+          <a:stretch>
+            <a:fillRect/>
+          </a:stretch>
+        </p:blipFill>
+        <p:spPr>
+          <a:xfrm>
+            <a:off x="6355080" y="2400300"/>
+            <a:ext cx="5486400" cy="3429000"/>
+          </a:xfrm>
+          <a:prstGeom prst="rect">
+            <a:avLst/>
+          </a:prstGeom>
+        </p:spPr>
+      </p:pic>
+    </p:spTree>
+  </p:cSld>
+  <p:clrMapOvr>
+    <a:masterClrMapping/>
+  </p:clrMapOvr>
+</p:sld>
+</file>
+
+<file path=ppt/slides/slide22.xml><?xml version="1.0" encoding="utf-8"?>
 <p:sld xmlns:a="http://schemas.openxmlformats.org/drawingml/2006/main" xmlns:p="http://schemas.openxmlformats.org/presentationml/2006/main" xmlns:r="http://schemas.openxmlformats.org/officeDocument/2006/relationships">
   <p:cSld>
     <p:bg>
@@ -16870,434 +17857,6 @@
                 </a:solidFill>
                 <a:latin typeface="Malgun Gothic"/>
               </a:rPr>
-              <a:t>19</a:t>
-            </a:r>
-          </a:p>
-        </p:txBody>
-      </p:sp>
-    </p:spTree>
-  </p:cSld>
-  <p:clrMapOvr>
-    <a:masterClrMapping/>
-  </p:clrMapOvr>
-</p:sld>
-</file>
-
-<file path=ppt/slides/slide22.xml><?xml version="1.0" encoding="utf-8"?>
-<p:sld xmlns:a="http://schemas.openxmlformats.org/drawingml/2006/main" xmlns:p="http://schemas.openxmlformats.org/presentationml/2006/main" xmlns:r="http://schemas.openxmlformats.org/officeDocument/2006/relationships">
-  <p:cSld>
-    <p:bg>
-      <p:bgPr>
-        <a:solidFill>
-          <a:srgbClr val="FFFFFF"/>
-        </a:solidFill>
-        <a:effectLst/>
-      </p:bgPr>
-    </p:bg>
-    <p:spTree>
-      <p:nvGrpSpPr>
-        <p:cNvPr id="1" name=""/>
-        <p:cNvGrpSpPr/>
-        <p:nvPr/>
-      </p:nvGrpSpPr>
-      <p:grpSpPr/>
-      <p:sp>
-        <p:nvSpPr>
-          <p:cNvPr id="2" name="Rectangle 1"/>
-          <p:cNvSpPr/>
-          <p:nvPr/>
-        </p:nvSpPr>
-        <p:spPr>
-          <a:xfrm>
-            <a:off x="0" y="0"/>
-            <a:ext cx="12191695" cy="566928"/>
-          </a:xfrm>
-          <a:prstGeom prst="rect">
-            <a:avLst/>
-          </a:prstGeom>
-          <a:solidFill>
-            <a:srgbClr val="E11D48"/>
-          </a:solidFill>
-          <a:ln>
-            <a:noFill/>
-          </a:ln>
-          <a:effectLst/>
-        </p:spPr>
-        <p:style>
-          <a:lnRef idx="1">
-            <a:schemeClr val="accent1"/>
-          </a:lnRef>
-          <a:fillRef idx="3">
-            <a:schemeClr val="accent1"/>
-          </a:fillRef>
-          <a:effectRef idx="2">
-            <a:schemeClr val="accent1"/>
-          </a:effectRef>
-          <a:fontRef idx="minor">
-            <a:schemeClr val="lt1"/>
-          </a:fontRef>
-        </p:style>
-        <p:txBody>
-          <a:bodyPr rtlCol="0" anchor="ctr"/>
-          <a:lstStyle/>
-          <a:p>
-            <a:pPr algn="ctr"/>
-          </a:p>
-        </p:txBody>
-      </p:sp>
-      <p:sp>
-        <p:nvSpPr>
-          <p:cNvPr id="3" name="Rectangle 2"/>
-          <p:cNvSpPr/>
-          <p:nvPr/>
-        </p:nvSpPr>
-        <p:spPr>
-          <a:xfrm>
-            <a:off x="0" y="566928"/>
-            <a:ext cx="12191695" cy="54864"/>
-          </a:xfrm>
-          <a:prstGeom prst="rect">
-            <a:avLst/>
-          </a:prstGeom>
-          <a:solidFill>
-            <a:srgbClr val="0EA5E9"/>
-          </a:solidFill>
-          <a:ln>
-            <a:noFill/>
-          </a:ln>
-          <a:effectLst/>
-        </p:spPr>
-        <p:style>
-          <a:lnRef idx="1">
-            <a:schemeClr val="accent1"/>
-          </a:lnRef>
-          <a:fillRef idx="3">
-            <a:schemeClr val="accent1"/>
-          </a:fillRef>
-          <a:effectRef idx="2">
-            <a:schemeClr val="accent1"/>
-          </a:effectRef>
-          <a:fontRef idx="minor">
-            <a:schemeClr val="lt1"/>
-          </a:fontRef>
-        </p:style>
-        <p:txBody>
-          <a:bodyPr rtlCol="0" anchor="ctr"/>
-          <a:lstStyle/>
-          <a:p>
-            <a:pPr algn="ctr"/>
-          </a:p>
-        </p:txBody>
-      </p:sp>
-      <p:sp>
-        <p:nvSpPr>
-          <p:cNvPr id="4" name="TextBox 3"/>
-          <p:cNvSpPr txBox="1"/>
-          <p:nvPr/>
-        </p:nvSpPr>
-        <p:spPr>
-          <a:xfrm>
-            <a:off x="365760" y="27432"/>
-            <a:ext cx="7315200" cy="502920"/>
-          </a:xfrm>
-          <a:prstGeom prst="rect">
-            <a:avLst/>
-          </a:prstGeom>
-          <a:noFill/>
-        </p:spPr>
-        <p:txBody>
-          <a:bodyPr wrap="square" anchor="ctr">
-            <a:spAutoFit/>
-          </a:bodyPr>
-          <a:lstStyle/>
-          <a:p>
-            <a:pPr algn="l">
-              <a:lnSpc>
-                <a:spcPct val="100000"/>
-              </a:lnSpc>
-            </a:pPr>
-            <a:r>
-              <a:rPr sz="1500" b="1">
-                <a:solidFill>
-                  <a:srgbClr val="FFFFFF"/>
-                </a:solidFill>
-                <a:latin typeface="Malgun Gothic"/>
-              </a:rPr>
-              <a:t>🤝 Mangoi Agency User Guide</a:t>
-            </a:r>
-          </a:p>
-        </p:txBody>
-      </p:sp>
-      <p:sp>
-        <p:nvSpPr>
-          <p:cNvPr id="5" name="TextBox 4"/>
-          <p:cNvSpPr txBox="1"/>
-          <p:nvPr/>
-        </p:nvSpPr>
-        <p:spPr>
-          <a:xfrm>
-            <a:off x="8168335" y="27432"/>
-            <a:ext cx="3657600" cy="502920"/>
-          </a:xfrm>
-          <a:prstGeom prst="rect">
-            <a:avLst/>
-          </a:prstGeom>
-          <a:noFill/>
-        </p:spPr>
-        <p:txBody>
-          <a:bodyPr wrap="square" anchor="ctr">
-            <a:spAutoFit/>
-          </a:bodyPr>
-          <a:lstStyle/>
-          <a:p>
-            <a:pPr algn="r">
-              <a:lnSpc>
-                <a:spcPct val="100000"/>
-              </a:lnSpc>
-            </a:pPr>
-            <a:r>
-              <a:rPr sz="1300" b="1">
-                <a:solidFill>
-                  <a:srgbClr val="F1F5F9"/>
-                </a:solidFill>
-                <a:latin typeface="Malgun Gothic"/>
-              </a:rPr>
-              <a:t>Data at a Glance</a:t>
-            </a:r>
-          </a:p>
-        </p:txBody>
-      </p:sp>
-      <p:sp>
-        <p:nvSpPr>
-          <p:cNvPr id="6" name="TextBox 5"/>
-          <p:cNvSpPr txBox="1"/>
-          <p:nvPr/>
-        </p:nvSpPr>
-        <p:spPr>
-          <a:xfrm>
-            <a:off x="987552" y="868680"/>
-            <a:ext cx="9144000" cy="457200"/>
-          </a:xfrm>
-          <a:prstGeom prst="rect">
-            <a:avLst/>
-          </a:prstGeom>
-          <a:noFill/>
-        </p:spPr>
-        <p:txBody>
-          <a:bodyPr wrap="square" anchor="t">
-            <a:spAutoFit/>
-          </a:bodyPr>
-          <a:lstStyle/>
-          <a:p>
-            <a:pPr algn="l">
-              <a:lnSpc>
-                <a:spcPct val="100000"/>
-              </a:lnSpc>
-            </a:pPr>
-            <a:r>
-              <a:rPr sz="2200" b="1">
-                <a:solidFill>
-                  <a:srgbClr val="E11D48"/>
-                </a:solidFill>
-                <a:latin typeface="Malgun Gothic"/>
-              </a:rPr>
-              <a:t>📊 Data at a Glance</a:t>
-            </a:r>
-          </a:p>
-        </p:txBody>
-      </p:sp>
-      <p:sp>
-        <p:nvSpPr>
-          <p:cNvPr id="7" name="TextBox 6"/>
-          <p:cNvSpPr txBox="1"/>
-          <p:nvPr/>
-        </p:nvSpPr>
-        <p:spPr>
-          <a:xfrm>
-            <a:off x="457200" y="1554480"/>
-            <a:ext cx="5486400" cy="365760"/>
-          </a:xfrm>
-          <a:prstGeom prst="rect">
-            <a:avLst/>
-          </a:prstGeom>
-          <a:noFill/>
-        </p:spPr>
-        <p:txBody>
-          <a:bodyPr wrap="square" anchor="t">
-            <a:spAutoFit/>
-          </a:bodyPr>
-          <a:lstStyle/>
-          <a:p>
-            <a:pPr algn="l">
-              <a:lnSpc>
-                <a:spcPct val="100000"/>
-              </a:lnSpc>
-            </a:pPr>
-            <a:r>
-              <a:rPr sz="1400" b="1">
-                <a:solidFill>
-                  <a:srgbClr val="1E2340"/>
-                </a:solidFill>
-                <a:latin typeface="Malgun Gothic"/>
-              </a:rPr>
-              <a:t>Enrollment Trend (example)</a:t>
-            </a:r>
-          </a:p>
-        </p:txBody>
-      </p:sp>
-      <p:graphicFrame>
-        <p:nvGraphicFramePr>
-          <p:cNvPr id="8" name="Chart 7"/>
-          <p:cNvGraphicFramePr>
-            <a:graphicFrameLocks noGrp="1"/>
-          </p:cNvGraphicFramePr>
-          <p:nvPr/>
-        </p:nvGraphicFramePr>
-        <p:xfrm>
-          <a:off x="457200" y="1920240"/>
-          <a:ext cx="5486400" cy="4206240"/>
-        </p:xfrm>
-        <a:graphic>
-          <a:graphicData uri="http://schemas.openxmlformats.org/drawingml/2006/chart">
-            <c:chart xmlns:c="http://schemas.openxmlformats.org/drawingml/2006/chart" r:id="rId2"/>
-          </a:graphicData>
-        </a:graphic>
-      </p:graphicFrame>
-      <p:sp>
-        <p:nvSpPr>
-          <p:cNvPr id="9" name="TextBox 8"/>
-          <p:cNvSpPr txBox="1"/>
-          <p:nvPr/>
-        </p:nvSpPr>
-        <p:spPr>
-          <a:xfrm>
-            <a:off x="6309360" y="1554480"/>
-            <a:ext cx="5486400" cy="365760"/>
-          </a:xfrm>
-          <a:prstGeom prst="rect">
-            <a:avLst/>
-          </a:prstGeom>
-          <a:noFill/>
-        </p:spPr>
-        <p:txBody>
-          <a:bodyPr wrap="square" anchor="t">
-            <a:spAutoFit/>
-          </a:bodyPr>
-          <a:lstStyle/>
-          <a:p>
-            <a:pPr algn="l">
-              <a:lnSpc>
-                <a:spcPct val="100000"/>
-              </a:lnSpc>
-            </a:pPr>
-            <a:r>
-              <a:rPr sz="1400" b="1">
-                <a:solidFill>
-                  <a:srgbClr val="1E2340"/>
-                </a:solidFill>
-                <a:latin typeface="Malgun Gothic"/>
-              </a:rPr>
-              <a:t>Churn-risk Distribution (example)</a:t>
-            </a:r>
-          </a:p>
-        </p:txBody>
-      </p:sp>
-      <p:graphicFrame>
-        <p:nvGraphicFramePr>
-          <p:cNvPr id="10" name="Chart 9"/>
-          <p:cNvGraphicFramePr>
-            <a:graphicFrameLocks noGrp="1"/>
-          </p:cNvGraphicFramePr>
-          <p:nvPr/>
-        </p:nvGraphicFramePr>
-        <p:xfrm>
-          <a:off x="6309360" y="1920240"/>
-          <a:ext cx="5486400" cy="4206240"/>
-        </p:xfrm>
-        <a:graphic>
-          <a:graphicData uri="http://schemas.openxmlformats.org/drawingml/2006/chart">
-            <c:chart xmlns:c="http://schemas.openxmlformats.org/drawingml/2006/chart" r:id="rId3"/>
-          </a:graphicData>
-        </a:graphic>
-      </p:graphicFrame>
-      <p:sp>
-        <p:nvSpPr>
-          <p:cNvPr id="6" name="Rounded Rectangle 5"/>
-          <p:cNvSpPr/>
-          <p:nvPr/>
-        </p:nvSpPr>
-        <p:spPr>
-          <a:xfrm>
-            <a:off x="365760" y="841247"/>
-            <a:ext cx="475488" cy="475488"/>
-          </a:xfrm>
-          <a:prstGeom prst="roundRect">
-            <a:avLst/>
-          </a:prstGeom>
-          <a:solidFill>
-            <a:srgbClr val="E11D48"/>
-          </a:solidFill>
-          <a:ln>
-            <a:noFill/>
-          </a:ln>
-          <a:effectLst/>
-        </p:spPr>
-        <p:style>
-          <a:lnRef idx="1">
-            <a:schemeClr val="accent1"/>
-          </a:lnRef>
-          <a:fillRef idx="3">
-            <a:schemeClr val="accent1"/>
-          </a:fillRef>
-          <a:effectRef idx="2">
-            <a:schemeClr val="accent1"/>
-          </a:effectRef>
-          <a:fontRef idx="minor">
-            <a:schemeClr val="lt1"/>
-          </a:fontRef>
-        </p:style>
-        <p:txBody>
-          <a:bodyPr rtlCol="0" anchor="ctr"/>
-          <a:lstStyle/>
-          <a:p>
-            <a:pPr algn="ctr"/>
-          </a:p>
-        </p:txBody>
-      </p:sp>
-      <p:sp>
-        <p:nvSpPr>
-          <p:cNvPr id="7" name="TextBox 6"/>
-          <p:cNvSpPr txBox="1"/>
-          <p:nvPr/>
-        </p:nvSpPr>
-        <p:spPr>
-          <a:xfrm>
-            <a:off x="365760" y="841247"/>
-            <a:ext cx="475488" cy="475488"/>
-          </a:xfrm>
-          <a:prstGeom prst="rect">
-            <a:avLst/>
-          </a:prstGeom>
-          <a:noFill/>
-        </p:spPr>
-        <p:txBody>
-          <a:bodyPr wrap="square" anchor="ctr">
-            <a:spAutoFit/>
-          </a:bodyPr>
-          <a:lstStyle/>
-          <a:p>
-            <a:pPr algn="ctr">
-              <a:lnSpc>
-                <a:spcPct val="100000"/>
-              </a:lnSpc>
-            </a:pPr>
-            <a:r>
-              <a:rPr sz="1500" b="1">
-                <a:solidFill>
-                  <a:srgbClr val="FFFFFF"/>
-                </a:solidFill>
-                <a:latin typeface="Malgun Gothic"/>
-              </a:rPr>
               <a:t>20</a:t>
             </a:r>
           </a:p>
@@ -17490,6 +18049,434 @@
                 </a:solidFill>
                 <a:latin typeface="Malgun Gothic"/>
               </a:rPr>
+              <a:t>Data at a Glance</a:t>
+            </a:r>
+          </a:p>
+        </p:txBody>
+      </p:sp>
+      <p:sp>
+        <p:nvSpPr>
+          <p:cNvPr id="6" name="TextBox 5"/>
+          <p:cNvSpPr txBox="1"/>
+          <p:nvPr/>
+        </p:nvSpPr>
+        <p:spPr>
+          <a:xfrm>
+            <a:off x="987552" y="868680"/>
+            <a:ext cx="9144000" cy="457200"/>
+          </a:xfrm>
+          <a:prstGeom prst="rect">
+            <a:avLst/>
+          </a:prstGeom>
+          <a:noFill/>
+        </p:spPr>
+        <p:txBody>
+          <a:bodyPr wrap="square" anchor="t">
+            <a:spAutoFit/>
+          </a:bodyPr>
+          <a:lstStyle/>
+          <a:p>
+            <a:pPr algn="l">
+              <a:lnSpc>
+                <a:spcPct val="100000"/>
+              </a:lnSpc>
+            </a:pPr>
+            <a:r>
+              <a:rPr sz="2200" b="1">
+                <a:solidFill>
+                  <a:srgbClr val="E11D48"/>
+                </a:solidFill>
+                <a:latin typeface="Malgun Gothic"/>
+              </a:rPr>
+              <a:t>📊 Data at a Glance</a:t>
+            </a:r>
+          </a:p>
+        </p:txBody>
+      </p:sp>
+      <p:sp>
+        <p:nvSpPr>
+          <p:cNvPr id="7" name="TextBox 6"/>
+          <p:cNvSpPr txBox="1"/>
+          <p:nvPr/>
+        </p:nvSpPr>
+        <p:spPr>
+          <a:xfrm>
+            <a:off x="457200" y="1554480"/>
+            <a:ext cx="5486400" cy="365760"/>
+          </a:xfrm>
+          <a:prstGeom prst="rect">
+            <a:avLst/>
+          </a:prstGeom>
+          <a:noFill/>
+        </p:spPr>
+        <p:txBody>
+          <a:bodyPr wrap="square" anchor="t">
+            <a:spAutoFit/>
+          </a:bodyPr>
+          <a:lstStyle/>
+          <a:p>
+            <a:pPr algn="l">
+              <a:lnSpc>
+                <a:spcPct val="100000"/>
+              </a:lnSpc>
+            </a:pPr>
+            <a:r>
+              <a:rPr sz="1400" b="1">
+                <a:solidFill>
+                  <a:srgbClr val="1E2340"/>
+                </a:solidFill>
+                <a:latin typeface="Malgun Gothic"/>
+              </a:rPr>
+              <a:t>Enrollment Trend (example)</a:t>
+            </a:r>
+          </a:p>
+        </p:txBody>
+      </p:sp>
+      <p:graphicFrame>
+        <p:nvGraphicFramePr>
+          <p:cNvPr id="8" name="Chart 7"/>
+          <p:cNvGraphicFramePr>
+            <a:graphicFrameLocks noGrp="1"/>
+          </p:cNvGraphicFramePr>
+          <p:nvPr/>
+        </p:nvGraphicFramePr>
+        <p:xfrm>
+          <a:off x="457200" y="1920240"/>
+          <a:ext cx="5486400" cy="4206240"/>
+        </p:xfrm>
+        <a:graphic>
+          <a:graphicData uri="http://schemas.openxmlformats.org/drawingml/2006/chart">
+            <c:chart xmlns:c="http://schemas.openxmlformats.org/drawingml/2006/chart" r:id="rId2"/>
+          </a:graphicData>
+        </a:graphic>
+      </p:graphicFrame>
+      <p:sp>
+        <p:nvSpPr>
+          <p:cNvPr id="9" name="TextBox 8"/>
+          <p:cNvSpPr txBox="1"/>
+          <p:nvPr/>
+        </p:nvSpPr>
+        <p:spPr>
+          <a:xfrm>
+            <a:off x="6309360" y="1554480"/>
+            <a:ext cx="5486400" cy="365760"/>
+          </a:xfrm>
+          <a:prstGeom prst="rect">
+            <a:avLst/>
+          </a:prstGeom>
+          <a:noFill/>
+        </p:spPr>
+        <p:txBody>
+          <a:bodyPr wrap="square" anchor="t">
+            <a:spAutoFit/>
+          </a:bodyPr>
+          <a:lstStyle/>
+          <a:p>
+            <a:pPr algn="l">
+              <a:lnSpc>
+                <a:spcPct val="100000"/>
+              </a:lnSpc>
+            </a:pPr>
+            <a:r>
+              <a:rPr sz="1400" b="1">
+                <a:solidFill>
+                  <a:srgbClr val="1E2340"/>
+                </a:solidFill>
+                <a:latin typeface="Malgun Gothic"/>
+              </a:rPr>
+              <a:t>Churn-risk Distribution (example)</a:t>
+            </a:r>
+          </a:p>
+        </p:txBody>
+      </p:sp>
+      <p:graphicFrame>
+        <p:nvGraphicFramePr>
+          <p:cNvPr id="10" name="Chart 9"/>
+          <p:cNvGraphicFramePr>
+            <a:graphicFrameLocks noGrp="1"/>
+          </p:cNvGraphicFramePr>
+          <p:nvPr/>
+        </p:nvGraphicFramePr>
+        <p:xfrm>
+          <a:off x="6309360" y="1920240"/>
+          <a:ext cx="5486400" cy="4206240"/>
+        </p:xfrm>
+        <a:graphic>
+          <a:graphicData uri="http://schemas.openxmlformats.org/drawingml/2006/chart">
+            <c:chart xmlns:c="http://schemas.openxmlformats.org/drawingml/2006/chart" r:id="rId3"/>
+          </a:graphicData>
+        </a:graphic>
+      </p:graphicFrame>
+      <p:sp>
+        <p:nvSpPr>
+          <p:cNvPr id="6" name="Rounded Rectangle 5"/>
+          <p:cNvSpPr/>
+          <p:nvPr/>
+        </p:nvSpPr>
+        <p:spPr>
+          <a:xfrm>
+            <a:off x="365760" y="841247"/>
+            <a:ext cx="475488" cy="475488"/>
+          </a:xfrm>
+          <a:prstGeom prst="roundRect">
+            <a:avLst/>
+          </a:prstGeom>
+          <a:solidFill>
+            <a:srgbClr val="E11D48"/>
+          </a:solidFill>
+          <a:ln>
+            <a:noFill/>
+          </a:ln>
+          <a:effectLst/>
+        </p:spPr>
+        <p:style>
+          <a:lnRef idx="1">
+            <a:schemeClr val="accent1"/>
+          </a:lnRef>
+          <a:fillRef idx="3">
+            <a:schemeClr val="accent1"/>
+          </a:fillRef>
+          <a:effectRef idx="2">
+            <a:schemeClr val="accent1"/>
+          </a:effectRef>
+          <a:fontRef idx="minor">
+            <a:schemeClr val="lt1"/>
+          </a:fontRef>
+        </p:style>
+        <p:txBody>
+          <a:bodyPr rtlCol="0" anchor="ctr"/>
+          <a:lstStyle/>
+          <a:p>
+            <a:pPr algn="ctr"/>
+          </a:p>
+        </p:txBody>
+      </p:sp>
+      <p:sp>
+        <p:nvSpPr>
+          <p:cNvPr id="7" name="TextBox 6"/>
+          <p:cNvSpPr txBox="1"/>
+          <p:nvPr/>
+        </p:nvSpPr>
+        <p:spPr>
+          <a:xfrm>
+            <a:off x="365760" y="841247"/>
+            <a:ext cx="475488" cy="475488"/>
+          </a:xfrm>
+          <a:prstGeom prst="rect">
+            <a:avLst/>
+          </a:prstGeom>
+          <a:noFill/>
+        </p:spPr>
+        <p:txBody>
+          <a:bodyPr wrap="square" anchor="ctr">
+            <a:spAutoFit/>
+          </a:bodyPr>
+          <a:lstStyle/>
+          <a:p>
+            <a:pPr algn="ctr">
+              <a:lnSpc>
+                <a:spcPct val="100000"/>
+              </a:lnSpc>
+            </a:pPr>
+            <a:r>
+              <a:rPr sz="1500" b="1">
+                <a:solidFill>
+                  <a:srgbClr val="FFFFFF"/>
+                </a:solidFill>
+                <a:latin typeface="Malgun Gothic"/>
+              </a:rPr>
+              <a:t>21</a:t>
+            </a:r>
+          </a:p>
+        </p:txBody>
+      </p:sp>
+    </p:spTree>
+  </p:cSld>
+  <p:clrMapOvr>
+    <a:masterClrMapping/>
+  </p:clrMapOvr>
+</p:sld>
+</file>
+
+<file path=ppt/slides/slide24.xml><?xml version="1.0" encoding="utf-8"?>
+<p:sld xmlns:a="http://schemas.openxmlformats.org/drawingml/2006/main" xmlns:p="http://schemas.openxmlformats.org/presentationml/2006/main" xmlns:r="http://schemas.openxmlformats.org/officeDocument/2006/relationships">
+  <p:cSld>
+    <p:bg>
+      <p:bgPr>
+        <a:solidFill>
+          <a:srgbClr val="FFFFFF"/>
+        </a:solidFill>
+        <a:effectLst/>
+      </p:bgPr>
+    </p:bg>
+    <p:spTree>
+      <p:nvGrpSpPr>
+        <p:cNvPr id="1" name=""/>
+        <p:cNvGrpSpPr/>
+        <p:nvPr/>
+      </p:nvGrpSpPr>
+      <p:grpSpPr/>
+      <p:sp>
+        <p:nvSpPr>
+          <p:cNvPr id="2" name="Rectangle 1"/>
+          <p:cNvSpPr/>
+          <p:nvPr/>
+        </p:nvSpPr>
+        <p:spPr>
+          <a:xfrm>
+            <a:off x="0" y="0"/>
+            <a:ext cx="12191695" cy="566928"/>
+          </a:xfrm>
+          <a:prstGeom prst="rect">
+            <a:avLst/>
+          </a:prstGeom>
+          <a:solidFill>
+            <a:srgbClr val="E11D48"/>
+          </a:solidFill>
+          <a:ln>
+            <a:noFill/>
+          </a:ln>
+          <a:effectLst/>
+        </p:spPr>
+        <p:style>
+          <a:lnRef idx="1">
+            <a:schemeClr val="accent1"/>
+          </a:lnRef>
+          <a:fillRef idx="3">
+            <a:schemeClr val="accent1"/>
+          </a:fillRef>
+          <a:effectRef idx="2">
+            <a:schemeClr val="accent1"/>
+          </a:effectRef>
+          <a:fontRef idx="minor">
+            <a:schemeClr val="lt1"/>
+          </a:fontRef>
+        </p:style>
+        <p:txBody>
+          <a:bodyPr rtlCol="0" anchor="ctr"/>
+          <a:lstStyle/>
+          <a:p>
+            <a:pPr algn="ctr"/>
+          </a:p>
+        </p:txBody>
+      </p:sp>
+      <p:sp>
+        <p:nvSpPr>
+          <p:cNvPr id="3" name="Rectangle 2"/>
+          <p:cNvSpPr/>
+          <p:nvPr/>
+        </p:nvSpPr>
+        <p:spPr>
+          <a:xfrm>
+            <a:off x="0" y="566928"/>
+            <a:ext cx="12191695" cy="54864"/>
+          </a:xfrm>
+          <a:prstGeom prst="rect">
+            <a:avLst/>
+          </a:prstGeom>
+          <a:solidFill>
+            <a:srgbClr val="0EA5E9"/>
+          </a:solidFill>
+          <a:ln>
+            <a:noFill/>
+          </a:ln>
+          <a:effectLst/>
+        </p:spPr>
+        <p:style>
+          <a:lnRef idx="1">
+            <a:schemeClr val="accent1"/>
+          </a:lnRef>
+          <a:fillRef idx="3">
+            <a:schemeClr val="accent1"/>
+          </a:fillRef>
+          <a:effectRef idx="2">
+            <a:schemeClr val="accent1"/>
+          </a:effectRef>
+          <a:fontRef idx="minor">
+            <a:schemeClr val="lt1"/>
+          </a:fontRef>
+        </p:style>
+        <p:txBody>
+          <a:bodyPr rtlCol="0" anchor="ctr"/>
+          <a:lstStyle/>
+          <a:p>
+            <a:pPr algn="ctr"/>
+          </a:p>
+        </p:txBody>
+      </p:sp>
+      <p:sp>
+        <p:nvSpPr>
+          <p:cNvPr id="4" name="TextBox 3"/>
+          <p:cNvSpPr txBox="1"/>
+          <p:nvPr/>
+        </p:nvSpPr>
+        <p:spPr>
+          <a:xfrm>
+            <a:off x="365760" y="27432"/>
+            <a:ext cx="7315200" cy="502920"/>
+          </a:xfrm>
+          <a:prstGeom prst="rect">
+            <a:avLst/>
+          </a:prstGeom>
+          <a:noFill/>
+        </p:spPr>
+        <p:txBody>
+          <a:bodyPr wrap="square" anchor="ctr">
+            <a:spAutoFit/>
+          </a:bodyPr>
+          <a:lstStyle/>
+          <a:p>
+            <a:pPr algn="l">
+              <a:lnSpc>
+                <a:spcPct val="100000"/>
+              </a:lnSpc>
+            </a:pPr>
+            <a:r>
+              <a:rPr sz="1500" b="1">
+                <a:solidFill>
+                  <a:srgbClr val="FFFFFF"/>
+                </a:solidFill>
+                <a:latin typeface="Malgun Gothic"/>
+              </a:rPr>
+              <a:t>🤝 Mangoi Agency User Guide</a:t>
+            </a:r>
+          </a:p>
+        </p:txBody>
+      </p:sp>
+      <p:sp>
+        <p:nvSpPr>
+          <p:cNvPr id="5" name="TextBox 4"/>
+          <p:cNvSpPr txBox="1"/>
+          <p:nvPr/>
+        </p:nvSpPr>
+        <p:spPr>
+          <a:xfrm>
+            <a:off x="8168335" y="27432"/>
+            <a:ext cx="3657600" cy="502920"/>
+          </a:xfrm>
+          <a:prstGeom prst="rect">
+            <a:avLst/>
+          </a:prstGeom>
+          <a:noFill/>
+        </p:spPr>
+        <p:txBody>
+          <a:bodyPr wrap="square" anchor="ctr">
+            <a:spAutoFit/>
+          </a:bodyPr>
+          <a:lstStyle/>
+          <a:p>
+            <a:pPr algn="r">
+              <a:lnSpc>
+                <a:spcPct val="100000"/>
+              </a:lnSpc>
+            </a:pPr>
+            <a:r>
+              <a:rPr sz="1300" b="1">
+                <a:solidFill>
+                  <a:srgbClr val="F1F5F9"/>
+                </a:solidFill>
+                <a:latin typeface="Malgun Gothic"/>
+              </a:rPr>
               <a:t>Frequently Asked Questions (FAQ)</a:t>
             </a:r>
           </a:p>
@@ -18232,7 +19219,7 @@
                 </a:solidFill>
                 <a:latin typeface="Malgun Gothic"/>
               </a:rPr>
-              <a:t>21</a:t>
+              <a:t>22</a:t>
             </a:r>
           </a:p>
         </p:txBody>
@@ -18245,7 +19232,7 @@
 </p:sld>
 </file>
 
-<file path=ppt/slides/slide24.xml><?xml version="1.0" encoding="utf-8"?>
+<file path=ppt/slides/slide25.xml><?xml version="1.0" encoding="utf-8"?>
 <p:sld xmlns:a="http://schemas.openxmlformats.org/drawingml/2006/main" xmlns:p="http://schemas.openxmlformats.org/presentationml/2006/main" xmlns:r="http://schemas.openxmlformats.org/officeDocument/2006/relationships">
   <p:cSld>
     <p:bg>
@@ -19165,7 +20152,7 @@
                 </a:solidFill>
                 <a:latin typeface="Malgun Gothic"/>
               </a:rPr>
-              <a:t>22</a:t>
+              <a:t>23</a:t>
             </a:r>
           </a:p>
         </p:txBody>
@@ -19178,7 +20165,7 @@
 </p:sld>
 </file>
 
-<file path=ppt/slides/slide25.xml><?xml version="1.0" encoding="utf-8"?>
+<file path=ppt/slides/slide26.xml><?xml version="1.0" encoding="utf-8"?>
 <p:sld xmlns:a="http://schemas.openxmlformats.org/drawingml/2006/main" xmlns:p="http://schemas.openxmlformats.org/presentationml/2006/main" xmlns:r="http://schemas.openxmlformats.org/officeDocument/2006/relationships">
   <p:cSld>
     <p:bg>
@@ -20672,7 +21659,7 @@
                 </a:solidFill>
                 <a:latin typeface="Malgun Gothic"/>
               </a:rPr>
-              <a:t>23</a:t>
+              <a:t>24</a:t>
             </a:r>
           </a:p>
         </p:txBody>
@@ -20685,7 +21672,7 @@
 </p:sld>
 </file>
 
-<file path=ppt/slides/slide26.xml><?xml version="1.0" encoding="utf-8"?>
+<file path=ppt/slides/slide27.xml><?xml version="1.0" encoding="utf-8"?>
 <p:sld xmlns:a="http://schemas.openxmlformats.org/drawingml/2006/main" xmlns:p="http://schemas.openxmlformats.org/presentationml/2006/main" xmlns:r="http://schemas.openxmlformats.org/officeDocument/2006/relationships">
   <p:cSld>
     <p:bg>
@@ -20960,7 +21947,7 @@
 </p:sld>
 </file>
 
-<file path=ppt/slides/slide27.xml><?xml version="1.0" encoding="utf-8"?>
+<file path=ppt/slides/slide28.xml><?xml version="1.0" encoding="utf-8"?>
 <p:sld xmlns:a="http://schemas.openxmlformats.org/drawingml/2006/main" xmlns:p="http://schemas.openxmlformats.org/presentationml/2006/main" xmlns:r="http://schemas.openxmlformats.org/officeDocument/2006/relationships">
   <p:cSld>
     <p:spTree>
@@ -21194,7 +22181,7 @@
           <a:p>
             <a:pPr>
               <a:spcAft>
-                <a:spcPts val="1935"/>
+                <a:spcPts val="1671"/>
               </a:spcAft>
             </a:pPr>
             <a:r>
@@ -21228,7 +22215,7 @@
           <a:p>
             <a:pPr>
               <a:spcAft>
-                <a:spcPts val="1935"/>
+                <a:spcPts val="1671"/>
               </a:spcAft>
             </a:pPr>
             <a:r>
@@ -21262,7 +22249,7 @@
           <a:p>
             <a:pPr>
               <a:spcAft>
-                <a:spcPts val="1935"/>
+                <a:spcPts val="1671"/>
               </a:spcAft>
             </a:pPr>
             <a:r>
@@ -21296,7 +22283,7 @@
           <a:p>
             <a:pPr>
               <a:spcAft>
-                <a:spcPts val="1935"/>
+                <a:spcPts val="1671"/>
               </a:spcAft>
             </a:pPr>
             <a:r>
@@ -21330,7 +22317,7 @@
           <a:p>
             <a:pPr>
               <a:spcAft>
-                <a:spcPts val="1935"/>
+                <a:spcPts val="1671"/>
               </a:spcAft>
             </a:pPr>
             <a:r>
@@ -21364,7 +22351,7 @@
           <a:p>
             <a:pPr>
               <a:spcAft>
-                <a:spcPts val="1935"/>
+                <a:spcPts val="1671"/>
               </a:spcAft>
             </a:pPr>
             <a:r>
@@ -21398,7 +22385,7 @@
           <a:p>
             <a:pPr>
               <a:spcAft>
-                <a:spcPts val="1935"/>
+                <a:spcPts val="1671"/>
               </a:spcAft>
             </a:pPr>
             <a:r>
@@ -21432,7 +22419,7 @@
           <a:p>
             <a:pPr>
               <a:spcAft>
-                <a:spcPts val="1935"/>
+                <a:spcPts val="1671"/>
               </a:spcAft>
             </a:pPr>
             <a:r>
@@ -21466,7 +22453,7 @@
           <a:p>
             <a:pPr>
               <a:spcAft>
-                <a:spcPts val="1935"/>
+                <a:spcPts val="1671"/>
               </a:spcAft>
             </a:pPr>
             <a:r>
@@ -21500,7 +22487,7 @@
           <a:p>
             <a:pPr>
               <a:spcAft>
-                <a:spcPts val="1935"/>
+                <a:spcPts val="1671"/>
               </a:spcAft>
             </a:pPr>
             <a:r>
@@ -21534,7 +22521,7 @@
           <a:p>
             <a:pPr>
               <a:spcAft>
-                <a:spcPts val="1935"/>
+                <a:spcPts val="1671"/>
               </a:spcAft>
             </a:pPr>
             <a:r>
@@ -21568,7 +22555,7 @@
           <a:p>
             <a:pPr>
               <a:spcAft>
-                <a:spcPts val="1935"/>
+                <a:spcPts val="1671"/>
               </a:spcAft>
             </a:pPr>
             <a:r>
@@ -21597,6 +22584,40 @@
                 <a:latin typeface="Malgun Gothic"/>
               </a:rPr>
               <a:t>   ·  p.14</a:t>
+            </a:r>
+          </a:p>
+          <a:p>
+            <a:pPr>
+              <a:spcAft>
+                <a:spcPts val="1671"/>
+              </a:spcAft>
+            </a:pPr>
+            <a:r>
+              <a:rPr sz="1100" b="1">
+                <a:solidFill>
+                  <a:srgbClr val="4F46E5"/>
+                </a:solidFill>
+                <a:latin typeface="Malgun Gothic"/>
+              </a:rPr>
+              <a:t>12  </a:t>
+            </a:r>
+            <a:r>
+              <a:rPr sz="1100">
+                <a:solidFill>
+                  <a:srgbClr val="334155"/>
+                </a:solidFill>
+                <a:latin typeface="Malgun Gothic"/>
+              </a:rPr>
+              <a:t>💬 New Counseling·Recruiting</a:t>
+            </a:r>
+            <a:r>
+              <a:rPr sz="950">
+                <a:solidFill>
+                  <a:srgbClr val="94A3B8"/>
+                </a:solidFill>
+                <a:latin typeface="Malgun Gothic"/>
+              </a:rPr>
+              <a:t>   ·  p.15</a:t>
             </a:r>
           </a:p>
         </p:txBody>
@@ -21625,7 +22646,7 @@
           <a:p>
             <a:pPr>
               <a:spcAft>
-                <a:spcPts val="1935"/>
+                <a:spcPts val="1671"/>
               </a:spcAft>
             </a:pPr>
             <a:r>
@@ -21635,7 +22656,7 @@
                 </a:solidFill>
                 <a:latin typeface="Malgun Gothic"/>
               </a:rPr>
-              <a:t>12  </a:t>
+              <a:t>13  </a:t>
             </a:r>
             <a:r>
               <a:rPr sz="1100">
@@ -21644,7 +22665,7 @@
                 </a:solidFill>
                 <a:latin typeface="Malgun Gothic"/>
               </a:rPr>
-              <a:t>💬 New Counseling·Recruiting</a:t>
+              <a:t>🎧 Support·Help</a:t>
             </a:r>
             <a:r>
               <a:rPr sz="950">
@@ -21653,13 +22674,13 @@
                 </a:solidFill>
                 <a:latin typeface="Malgun Gothic"/>
               </a:rPr>
-              <a:t>   ·  p.15</a:t>
+              <a:t>   ·  p.16</a:t>
             </a:r>
           </a:p>
           <a:p>
             <a:pPr>
               <a:spcAft>
-                <a:spcPts val="1935"/>
+                <a:spcPts val="1671"/>
               </a:spcAft>
             </a:pPr>
             <a:r>
@@ -21669,7 +22690,7 @@
                 </a:solidFill>
                 <a:latin typeface="Malgun Gothic"/>
               </a:rPr>
-              <a:t>13  </a:t>
+              <a:t>14  </a:t>
             </a:r>
             <a:r>
               <a:rPr sz="1100">
@@ -21678,7 +22699,7 @@
                 </a:solidFill>
                 <a:latin typeface="Malgun Gothic"/>
               </a:rPr>
-              <a:t>🎧 Support·Help</a:t>
+              <a:t>🕐 Korea·Philippines Dual Clo…</a:t>
             </a:r>
             <a:r>
               <a:rPr sz="950">
@@ -21687,13 +22708,13 @@
                 </a:solidFill>
                 <a:latin typeface="Malgun Gothic"/>
               </a:rPr>
-              <a:t>   ·  p.16</a:t>
+              <a:t>   ·  p.17</a:t>
             </a:r>
           </a:p>
           <a:p>
             <a:pPr>
               <a:spcAft>
-                <a:spcPts val="1935"/>
+                <a:spcPts val="1671"/>
               </a:spcAft>
             </a:pPr>
             <a:r>
@@ -21703,7 +22724,7 @@
                 </a:solidFill>
                 <a:latin typeface="Malgun Gothic"/>
               </a:rPr>
-              <a:t>14  </a:t>
+              <a:t>15  </a:t>
             </a:r>
             <a:r>
               <a:rPr sz="1100">
@@ -21712,7 +22733,7 @@
                 </a:solidFill>
                 <a:latin typeface="Malgun Gothic"/>
               </a:rPr>
-              <a:t>🕐 Korea·Philippines Dual Clo…</a:t>
+              <a:t>🇨🇳 Chinese Pronunciation Coa…</a:t>
             </a:r>
             <a:r>
               <a:rPr sz="950">
@@ -21721,13 +22742,13 @@
                 </a:solidFill>
                 <a:latin typeface="Malgun Gothic"/>
               </a:rPr>
-              <a:t>   ·  p.17</a:t>
+              <a:t>   ·  p.18</a:t>
             </a:r>
           </a:p>
           <a:p>
             <a:pPr>
               <a:spcAft>
-                <a:spcPts val="1935"/>
+                <a:spcPts val="1671"/>
               </a:spcAft>
             </a:pPr>
             <a:r>
@@ -21737,7 +22758,7 @@
                 </a:solidFill>
                 <a:latin typeface="Malgun Gothic"/>
               </a:rPr>
-              <a:t>15  </a:t>
+              <a:t>16  </a:t>
             </a:r>
             <a:r>
               <a:rPr sz="1100">
@@ -21746,7 +22767,7 @@
                 </a:solidFill>
                 <a:latin typeface="Malgun Gothic"/>
               </a:rPr>
-              <a:t>🇨🇳 Chinese Pronunciation Coa…</a:t>
+              <a:t>🌟 In-class Praise Points (un…</a:t>
             </a:r>
             <a:r>
               <a:rPr sz="950">
@@ -21755,13 +22776,13 @@
                 </a:solidFill>
                 <a:latin typeface="Malgun Gothic"/>
               </a:rPr>
-              <a:t>   ·  p.18</a:t>
+              <a:t>   ·  p.19</a:t>
             </a:r>
           </a:p>
           <a:p>
             <a:pPr>
               <a:spcAft>
-                <a:spcPts val="1935"/>
+                <a:spcPts val="1671"/>
               </a:spcAft>
             </a:pPr>
             <a:r>
@@ -21771,7 +22792,7 @@
                 </a:solidFill>
                 <a:latin typeface="Malgun Gothic"/>
               </a:rPr>
-              <a:t>16  </a:t>
+              <a:t>17  </a:t>
             </a:r>
             <a:r>
               <a:rPr sz="1100">
@@ -21780,7 +22801,7 @@
                 </a:solidFill>
                 <a:latin typeface="Malgun Gothic"/>
               </a:rPr>
-              <a:t>🌟 In-class Praise Points (un…</a:t>
+              <a:t>📢 Notice Studio (Poster + Po…</a:t>
             </a:r>
             <a:r>
               <a:rPr sz="950">
@@ -21789,13 +22810,13 @@
                 </a:solidFill>
                 <a:latin typeface="Malgun Gothic"/>
               </a:rPr>
-              <a:t>   ·  p.19</a:t>
+              <a:t>   ·  p.20</a:t>
             </a:r>
           </a:p>
           <a:p>
             <a:pPr>
               <a:spcAft>
-                <a:spcPts val="1935"/>
+                <a:spcPts val="1671"/>
               </a:spcAft>
             </a:pPr>
             <a:r>
@@ -21805,7 +22826,7 @@
                 </a:solidFill>
                 <a:latin typeface="Malgun Gothic"/>
               </a:rPr>
-              <a:t>17  </a:t>
+              <a:t>18  </a:t>
             </a:r>
             <a:r>
               <a:rPr sz="1100">
@@ -21814,7 +22835,7 @@
                 </a:solidFill>
                 <a:latin typeface="Malgun Gothic"/>
               </a:rPr>
-              <a:t>📢 Notice Studio (Poster + Po…</a:t>
+              <a:t>🤖 Command the AI Operations …</a:t>
             </a:r>
             <a:r>
               <a:rPr sz="950">
@@ -21823,13 +22844,13 @@
                 </a:solidFill>
                 <a:latin typeface="Malgun Gothic"/>
               </a:rPr>
-              <a:t>   ·  p.20</a:t>
+              <a:t>   ·  p.21</a:t>
             </a:r>
           </a:p>
           <a:p>
             <a:pPr>
               <a:spcAft>
-                <a:spcPts val="1935"/>
+                <a:spcPts val="1671"/>
               </a:spcAft>
             </a:pPr>
             <a:r>
@@ -21839,7 +22860,7 @@
                 </a:solidFill>
                 <a:latin typeface="Malgun Gothic"/>
               </a:rPr>
-              <a:t>18  </a:t>
+              <a:t>19  </a:t>
             </a:r>
             <a:r>
               <a:rPr sz="1100">
@@ -21848,7 +22869,7 @@
                 </a:solidFill>
                 <a:latin typeface="Malgun Gothic"/>
               </a:rPr>
-              <a:t>🤖 Command the AI Operations …</a:t>
+              <a:t>💬 Share Library Links via Ka…</a:t>
             </a:r>
             <a:r>
               <a:rPr sz="950">
@@ -21857,13 +22878,13 @@
                 </a:solidFill>
                 <a:latin typeface="Malgun Gothic"/>
               </a:rPr>
-              <a:t>   ·  p.21</a:t>
+              <a:t>   ·  p.22</a:t>
             </a:r>
           </a:p>
           <a:p>
             <a:pPr>
               <a:spcAft>
-                <a:spcPts val="1935"/>
+                <a:spcPts val="1671"/>
               </a:spcAft>
             </a:pPr>
             <a:r>
@@ -21873,7 +22894,7 @@
                 </a:solidFill>
                 <a:latin typeface="Malgun Gothic"/>
               </a:rPr>
-              <a:t>19  </a:t>
+              <a:t>20  </a:t>
             </a:r>
             <a:r>
               <a:rPr sz="1100">
@@ -21891,13 +22912,13 @@
                 </a:solidFill>
                 <a:latin typeface="Malgun Gothic"/>
               </a:rPr>
-              <a:t>   ·  p.22</a:t>
+              <a:t>   ·  p.23</a:t>
             </a:r>
           </a:p>
           <a:p>
             <a:pPr>
               <a:spcAft>
-                <a:spcPts val="1935"/>
+                <a:spcPts val="1671"/>
               </a:spcAft>
             </a:pPr>
             <a:r>
@@ -21907,7 +22928,7 @@
                 </a:solidFill>
                 <a:latin typeface="Malgun Gothic"/>
               </a:rPr>
-              <a:t>20  </a:t>
+              <a:t>21  </a:t>
             </a:r>
             <a:r>
               <a:rPr sz="1100">
@@ -21925,13 +22946,13 @@
                 </a:solidFill>
                 <a:latin typeface="Malgun Gothic"/>
               </a:rPr>
-              <a:t>   ·  p.23</a:t>
+              <a:t>   ·  p.24</a:t>
             </a:r>
           </a:p>
           <a:p>
             <a:pPr>
               <a:spcAft>
-                <a:spcPts val="1935"/>
+                <a:spcPts val="1671"/>
               </a:spcAft>
             </a:pPr>
             <a:r>
@@ -21941,7 +22962,7 @@
                 </a:solidFill>
                 <a:latin typeface="Malgun Gothic"/>
               </a:rPr>
-              <a:t>21  </a:t>
+              <a:t>22  </a:t>
             </a:r>
             <a:r>
               <a:rPr sz="1100">
@@ -21959,13 +22980,13 @@
                 </a:solidFill>
                 <a:latin typeface="Malgun Gothic"/>
               </a:rPr>
-              <a:t>   ·  p.24</a:t>
+              <a:t>   ·  p.25</a:t>
             </a:r>
           </a:p>
           <a:p>
             <a:pPr>
               <a:spcAft>
-                <a:spcPts val="1935"/>
+                <a:spcPts val="1671"/>
               </a:spcAft>
             </a:pPr>
             <a:r>
@@ -21975,7 +22996,7 @@
                 </a:solidFill>
                 <a:latin typeface="Malgun Gothic"/>
               </a:rPr>
-              <a:t>22  </a:t>
+              <a:t>23  </a:t>
             </a:r>
             <a:r>
               <a:rPr sz="1100">
@@ -21993,13 +23014,13 @@
                 </a:solidFill>
                 <a:latin typeface="Malgun Gothic"/>
               </a:rPr>
-              <a:t>   ·  p.25</a:t>
+              <a:t>   ·  p.26</a:t>
             </a:r>
           </a:p>
           <a:p>
             <a:pPr>
               <a:spcAft>
-                <a:spcPts val="1935"/>
+                <a:spcPts val="1671"/>
               </a:spcAft>
             </a:pPr>
             <a:r>
@@ -22009,7 +23030,7 @@
                 </a:solidFill>
                 <a:latin typeface="Malgun Gothic"/>
               </a:rPr>
-              <a:t>23  </a:t>
+              <a:t>24  </a:t>
             </a:r>
             <a:r>
               <a:rPr sz="1100">
@@ -22027,7 +23048,7 @@
                 </a:solidFill>
                 <a:latin typeface="Malgun Gothic"/>
               </a:rPr>
-              <a:t>   ·  p.26</a:t>
+              <a:t>   ·  p.27</a:t>
             </a:r>
           </a:p>
         </p:txBody>

</xml_diff>